<commit_message>
Final gate: submission checklist, report/doc fixes, regenerated quick artefacts
Co-Authored-By: Claude Opus 5.5 <noreply@anthropic.com>
</commit_message>
<xml_diff>
--- a/reports/slides.pptx
+++ b/reports/slides.pptx
@@ -861,7 +861,7 @@
           <a:lstStyle/>
           <a:p>
             <a:r>
-              <a:t>Step 3. Each AutoML tool got the same training split, ROC-AUC as the metric, 16 threads on the laptop and a 20-minute budget. On test_future AUC, AutoGluon is statistically tied with our tuned LightGBM, and FLAML and H2O AutoML are slightly worse; no tool is more than 0.0011 AUC away. The big difference is cost: AutoGluon took 20.2 minutes against 76.0 for the manual search we selected, with no search space to design. Every winner is in effect one gradient-boosted tree model.</a:t>
+              <a:t>Step 3. Each AutoML tool got the same training split, ROC-AUC as the metric, 16 threads on the laptop and a 20-minute budget. On test_future AUC, AutoGluon is statistically tied with our tuned LightGBM, and FLAML and H2O AutoML are slightly worse; no tool is more than 0.0011 AUC away. The big difference is cost: AutoGluon took 20.2 minutes against 76.0 for the manual search we selected and its refit, with no search space to design. Every winner is in effect one gradient-boosted tree model.</a:t>
             </a:r>
           </a:p>
         </p:txBody>
@@ -1141,7 +1141,7 @@
           <a:lstStyle/>
           <a:p>
             <a:r>
-              <a:t>Deployment. The tuned LightGBM is served by a FastAPI service and a Streamlit app; you can pick a test_future file or upload a PE file, and the app shows the score, the verdict and the top SHAP reasons. The threshold was chosen on train out-of-fold scores so that a missed malware costs 10 times a false alarm; on test_future that gives 99.5% recall at 7.4% false-positive rate. It is a triage aid, and the app says so; the model card lists the limits.</a:t>
+              <a:t>Deployment. The tuned LightGBM is served by a FastAPI service and a Streamlit app; you can pick a test_future file or upload a PE file, and the app shows the score, the verdict and the top SHAP reasons. The threshold was chosen on train out-of-fold scores so that a missed malware costs 10 times a false alarm; on test_future that gives 99.5% recall at 7.4% false-positive rate, but at a realistic 1% malware share only about 12% of its alarms would be real malware. So it is a triage aid, not a blocker, and the app says so; the model card lists the limits.</a:t>
             </a:r>
           </a:p>
         </p:txBody>
@@ -4566,20 +4566,12 @@
           </a:bodyPr>
           <a:lstStyle/>
           <a:p>
-            <a:pPr algn="l">
+            <a:pPr algn="l" marL="217170" indent="-217170">
               <a:spcAft>
                 <a:spcPts val="800"/>
               </a:spcAft>
+              <a:buChar char="•"/>
             </a:pPr>
-            <a:r>
-              <a:rPr sz="1900" b="0">
-                <a:solidFill>
-                  <a:srgbClr val="1F2A44"/>
-                </a:solidFill>
-                <a:latin typeface="Calibri"/>
-              </a:rPr>
-              <a:t>• </a:t>
-            </a:r>
             <a:r>
               <a:rPr sz="1900" b="0">
                 <a:solidFill>
@@ -4591,10 +4583,11 @@
             </a:r>
           </a:p>
           <a:p>
-            <a:pPr algn="l">
+            <a:pPr algn="l" marL="217170" indent="-217170">
               <a:spcAft>
                 <a:spcPts val="800"/>
               </a:spcAft>
+              <a:buChar char="•"/>
             </a:pPr>
             <a:r>
               <a:rPr sz="1900" b="0">
@@ -4603,33 +4596,16 @@
                 </a:solidFill>
                 <a:latin typeface="Calibri"/>
               </a:rPr>
-              <a:t>• </a:t>
-            </a:r>
-            <a:r>
-              <a:rPr sz="1900" b="0">
-                <a:solidFill>
-                  <a:srgbClr val="1F2A44"/>
-                </a:solidFill>
-                <a:latin typeface="Calibri"/>
-              </a:rPr>
-              <a:t>Random split overstates little by AUC (0.0010), a lot by precision at 1% prevalence (44.7% on future files).</a:t>
-            </a:r>
-          </a:p>
-          <a:p>
-            <a:pPr algn="l">
+              <a:t>The random split overstates little by AUC (0.0010); the 50/50 test mix overstates a lot: precision 98.8% vs 44.7% at 1% malware on future files.</a:t>
+            </a:r>
+          </a:p>
+          <a:p>
+            <a:pPr algn="l" marL="217170" indent="-217170">
               <a:spcAft>
                 <a:spcPts val="800"/>
               </a:spcAft>
+              <a:buChar char="•"/>
             </a:pPr>
-            <a:r>
-              <a:rPr sz="1900" b="0">
-                <a:solidFill>
-                  <a:srgbClr val="1F2A44"/>
-                </a:solidFill>
-                <a:latin typeface="Calibri"/>
-              </a:rPr>
-              <a:t>• </a:t>
-            </a:r>
             <a:r>
               <a:rPr sz="1900" b="0">
                 <a:solidFill>
@@ -4641,10 +4617,11 @@
             </a:r>
           </a:p>
           <a:p>
-            <a:pPr algn="l">
+            <a:pPr algn="l" marL="217170" indent="-217170">
               <a:spcAft>
                 <a:spcPts val="800"/>
               </a:spcAft>
+              <a:buChar char="•"/>
             </a:pPr>
             <a:r>
               <a:rPr sz="1900" b="0">
@@ -4653,16 +4630,7 @@
                 </a:solidFill>
                 <a:latin typeface="Calibri"/>
               </a:rPr>
-              <a:t>• </a:t>
-            </a:r>
-            <a:r>
-              <a:rPr sz="1900" b="0">
-                <a:solidFill>
-                  <a:srgbClr val="1F2A44"/>
-                </a:solidFill>
-                <a:latin typeface="Calibri"/>
-              </a:rPr>
-              <a:t>The hard tail: 53.7% of challenge-set malware caught.</a:t>
+              <a:t>The hard tail: 53.7% of challenge-set malware caught at 1% FPR (79.9% at the deployed threshold).</a:t>
             </a:r>
           </a:p>
         </p:txBody>
@@ -4728,20 +4696,12 @@
           </a:bodyPr>
           <a:lstStyle/>
           <a:p>
-            <a:pPr algn="l">
+            <a:pPr algn="l" marL="217170" indent="-217170">
               <a:spcAft>
                 <a:spcPts val="800"/>
               </a:spcAft>
+              <a:buChar char="•"/>
             </a:pPr>
-            <a:r>
-              <a:rPr sz="1900" b="0">
-                <a:solidFill>
-                  <a:srgbClr val="1F2A44"/>
-                </a:solidFill>
-                <a:latin typeface="Calibri"/>
-              </a:rPr>
-              <a:t>• </a:t>
-            </a:r>
             <a:r>
               <a:rPr sz="1900" b="0">
                 <a:solidFill>
@@ -4753,20 +4713,12 @@
             </a:r>
           </a:p>
           <a:p>
-            <a:pPr algn="l">
+            <a:pPr algn="l" marL="217170" indent="-217170">
               <a:spcAft>
                 <a:spcPts val="800"/>
               </a:spcAft>
+              <a:buChar char="•"/>
             </a:pPr>
-            <a:r>
-              <a:rPr sz="1900" b="0">
-                <a:solidFill>
-                  <a:srgbClr val="1F2A44"/>
-                </a:solidFill>
-                <a:latin typeface="Calibri"/>
-              </a:rPr>
-              <a:t>• </a:t>
-            </a:r>
             <a:r>
               <a:rPr sz="1900" b="0">
                 <a:solidFill>
@@ -4778,20 +4730,12 @@
             </a:r>
           </a:p>
           <a:p>
-            <a:pPr algn="l">
+            <a:pPr algn="l" marL="217170" indent="-217170">
               <a:spcAft>
                 <a:spcPts val="800"/>
               </a:spcAft>
+              <a:buChar char="•"/>
             </a:pPr>
-            <a:r>
-              <a:rPr sz="1900" b="0">
-                <a:solidFill>
-                  <a:srgbClr val="1F2A44"/>
-                </a:solidFill>
-                <a:latin typeface="Calibri"/>
-              </a:rPr>
-              <a:t>• </a:t>
-            </a:r>
             <a:r>
               <a:rPr sz="1900" b="0">
                 <a:solidFill>
@@ -4803,10 +4747,11 @@
             </a:r>
           </a:p>
           <a:p>
-            <a:pPr algn="l">
+            <a:pPr algn="l" marL="217170" indent="-217170">
               <a:spcAft>
                 <a:spcPts val="800"/>
               </a:spcAft>
+              <a:buChar char="•"/>
             </a:pPr>
             <a:r>
               <a:rPr sz="1900" b="0">
@@ -4815,16 +4760,7 @@
                 </a:solidFill>
                 <a:latin typeface="Calibri"/>
               </a:rPr>
-              <a:t>• </a:t>
-            </a:r>
-            <a:r>
-              <a:rPr sz="1900" b="0">
-                <a:solidFill>
-                  <a:srgbClr val="1F2A44"/>
-                </a:solidFill>
-                <a:latin typeface="Calibri"/>
-              </a:rPr>
-              <a:t>Step 4 ran on a 4-core / 15 GB cloud VM (600 s AutoML budget), Steps 2-3 on the 16-core laptop.</a:t>
+              <a:t>Step 4 ran on a 4-core / 15.7 GiB cloud VM (600 s AutoML budget), Steps 2-3 on the 16-core laptop.</a:t>
             </a:r>
           </a:p>
         </p:txBody>
@@ -5517,20 +5453,12 @@
           </a:bodyPr>
           <a:lstStyle/>
           <a:p>
-            <a:pPr algn="l">
+            <a:pPr algn="l" marL="205740" indent="-205740">
               <a:spcAft>
                 <a:spcPts val="800"/>
               </a:spcAft>
+              <a:buChar char="•"/>
             </a:pPr>
-            <a:r>
-              <a:rPr sz="1800" b="0">
-                <a:solidFill>
-                  <a:srgbClr val="5F6673"/>
-                </a:solidFill>
-                <a:latin typeface="Calibri"/>
-              </a:rPr>
-              <a:t>• </a:t>
-            </a:r>
             <a:r>
               <a:rPr sz="1800" b="0">
                 <a:solidFill>
@@ -5542,20 +5470,12 @@
             </a:r>
           </a:p>
           <a:p>
-            <a:pPr algn="l">
+            <a:pPr algn="l" marL="205740" indent="-205740">
               <a:spcAft>
                 <a:spcPts val="800"/>
               </a:spcAft>
+              <a:buChar char="•"/>
             </a:pPr>
-            <a:r>
-              <a:rPr sz="1800" b="0">
-                <a:solidFill>
-                  <a:srgbClr val="5F6673"/>
-                </a:solidFill>
-                <a:latin typeface="Calibri"/>
-              </a:rPr>
-              <a:t>• </a:t>
-            </a:r>
             <a:r>
               <a:rPr sz="1800" b="0">
                 <a:solidFill>
@@ -5567,20 +5487,12 @@
             </a:r>
           </a:p>
           <a:p>
-            <a:pPr algn="l">
+            <a:pPr algn="l" marL="205740" indent="-205740">
               <a:spcAft>
                 <a:spcPts val="800"/>
               </a:spcAft>
+              <a:buChar char="•"/>
             </a:pPr>
-            <a:r>
-              <a:rPr sz="1800" b="0">
-                <a:solidFill>
-                  <a:srgbClr val="5F6673"/>
-                </a:solidFill>
-                <a:latin typeface="Calibri"/>
-              </a:rPr>
-              <a:t>• </a:t>
-            </a:r>
             <a:r>
               <a:rPr sz="1800" b="0">
                 <a:solidFill>
@@ -6185,7 +6097,7 @@
         </p:nvSpPr>
         <p:spPr>
           <a:xfrm>
-            <a:off x="457200" y="3840480"/>
+            <a:off x="9153144" y="3840480"/>
             <a:ext cx="2514600" cy="1600200"/>
           </a:xfrm>
           <a:prstGeom prst="roundRect">
@@ -6267,16 +6179,16 @@
       </p:sp>
       <p:sp>
         <p:nvSpPr>
-          <p:cNvPr id="13" name="Right Arrow 12"/>
+          <p:cNvPr id="13" name="Left Arrow 12"/>
           <p:cNvSpPr/>
           <p:nvPr/>
         </p:nvSpPr>
         <p:spPr>
           <a:xfrm>
-            <a:off x="3017520" y="4503420"/>
+            <a:off x="8814816" y="4503420"/>
             <a:ext cx="292608" cy="274320"/>
           </a:xfrm>
-          <a:prstGeom prst="rightArrow">
+          <a:prstGeom prst="leftArrow">
             <a:avLst/>
           </a:prstGeom>
           <a:solidFill>
@@ -6316,7 +6228,7 @@
         </p:nvSpPr>
         <p:spPr>
           <a:xfrm>
-            <a:off x="3355848" y="3840480"/>
+            <a:off x="6254496" y="3840480"/>
             <a:ext cx="2514600" cy="1600200"/>
           </a:xfrm>
           <a:prstGeom prst="roundRect">
@@ -6398,7 +6310,7 @@
       </p:sp>
       <p:sp>
         <p:nvSpPr>
-          <p:cNvPr id="15" name="Right Arrow 14"/>
+          <p:cNvPr id="15" name="Left Arrow 14"/>
           <p:cNvSpPr/>
           <p:nvPr/>
         </p:nvSpPr>
@@ -6407,7 +6319,7 @@
             <a:off x="5916168" y="4503420"/>
             <a:ext cx="292608" cy="274320"/>
           </a:xfrm>
-          <a:prstGeom prst="rightArrow">
+          <a:prstGeom prst="leftArrow">
             <a:avLst/>
           </a:prstGeom>
           <a:solidFill>
@@ -6447,7 +6359,7 @@
         </p:nvSpPr>
         <p:spPr>
           <a:xfrm>
-            <a:off x="6254496" y="3840480"/>
+            <a:off x="3355848" y="3840480"/>
             <a:ext cx="2514600" cy="1600200"/>
           </a:xfrm>
           <a:prstGeom prst="roundRect">
@@ -6529,16 +6441,16 @@
       </p:sp>
       <p:sp>
         <p:nvSpPr>
-          <p:cNvPr id="17" name="Right Arrow 16"/>
+          <p:cNvPr id="17" name="Left Arrow 16"/>
           <p:cNvSpPr/>
           <p:nvPr/>
         </p:nvSpPr>
         <p:spPr>
           <a:xfrm>
-            <a:off x="8814816" y="4503420"/>
+            <a:off x="3017520" y="4503420"/>
             <a:ext cx="292608" cy="274320"/>
           </a:xfrm>
-          <a:prstGeom prst="rightArrow">
+          <a:prstGeom prst="leftArrow">
             <a:avLst/>
           </a:prstGeom>
           <a:solidFill>
@@ -6578,7 +6490,7 @@
         </p:nvSpPr>
         <p:spPr>
           <a:xfrm>
-            <a:off x="9153144" y="3840480"/>
+            <a:off x="457200" y="3840480"/>
             <a:ext cx="2514600" cy="1600200"/>
           </a:xfrm>
           <a:prstGeom prst="roundRect">
@@ -9038,7 +8950,7 @@
                 </a:solidFill>
                 <a:latin typeface="Calibri"/>
               </a:rPr>
-              <a:t>AutoGluon 20.2 min vs 76.0 min for the selected manual search; all three beat untuned LightGBM.</a:t>
+              <a:t>AutoGluon 20.2 min vs 76.0 min for the selected manual search and refit; all three beat untuned LightGBM.</a:t>
             </a:r>
           </a:p>
         </p:txBody>
@@ -9865,7 +9777,7 @@
                 </a:solidFill>
                 <a:latin typeface="Calibri"/>
               </a:rPr>
-              <a:t>only 53.7% of challenge-set malware is caught.</a:t>
+              <a:t>only 53.7% of challenge-set malware is caught at this threshold (79.9% at the deployed, recall-oriented one).</a:t>
             </a:r>
           </a:p>
         </p:txBody>
@@ -10004,7 +9916,7 @@
                 </a:solidFill>
                 <a:latin typeface="Calibri"/>
               </a:rPr>
-              <a:t>Source: reports/tables/leakage.csv, automl_self_estimate.csv; Step 4 ran on a 4-core / 15 GB Linux VM, 600 s per AutoML run</a:t>
+              <a:t>Source: reports/tables/leakage.csv, automl_self_estimate.csv; Step 4 ran on a 4-core / 15.7 GiB RAM Linux VM, 600 s per AutoML run</a:t>
             </a:r>
           </a:p>
         </p:txBody>
@@ -10837,7 +10749,7 @@
       </p:sp>
       <p:pic>
         <p:nvPicPr>
-          <p:cNvPr id="5" name="Picture 4" descr="shap_family_bar.png"/>
+          <p:cNvPr id="5" name="Picture 4" descr="image.png"/>
           <p:cNvPicPr>
             <a:picLocks noChangeAspect="1"/>
           </p:cNvPicPr>
@@ -11123,7 +11035,7 @@
       </p:sp>
       <p:pic>
         <p:nvPicPr>
-          <p:cNvPr id="5" name="Picture 4" descr="a_malicious_correct.png"/>
+          <p:cNvPr id="5" name="Picture 4" descr="image.png"/>
           <p:cNvPicPr>
             <a:picLocks noChangeAspect="1"/>
           </p:cNvPicPr>
@@ -11131,15 +11043,14 @@
         </p:nvPicPr>
         <p:blipFill>
           <a:blip r:embed="rId3"/>
-          <a:srcRect b="45000"/>
           <a:stretch>
             <a:fillRect/>
           </a:stretch>
         </p:blipFill>
         <p:spPr>
           <a:xfrm>
-            <a:off x="457200" y="1628775"/>
-            <a:ext cx="6035040" cy="4149090"/>
+            <a:off x="457200" y="1324555"/>
+            <a:ext cx="6400800" cy="4757530"/>
           </a:xfrm>
           <a:prstGeom prst="rect">
             <a:avLst/>
@@ -11154,8 +11065,8 @@
         </p:nvSpPr>
         <p:spPr>
           <a:xfrm>
-            <a:off x="6766560" y="1188720"/>
-            <a:ext cx="4937760" cy="5120640"/>
+            <a:off x="7132320" y="1188720"/>
+            <a:ext cx="4572000" cy="5120640"/>
           </a:xfrm>
           <a:prstGeom prst="rect">
             <a:avLst/>
@@ -11264,7 +11175,7 @@
                 </a:solidFill>
                 <a:latin typeface="Calibri"/>
               </a:rPr>
-              <a:t>recall 99.5%, FPR 7.4%.</a:t>
+              <a:t>recall 99.5%, FPR 7.4%; at 1% malware ~12% precision, so triage, not blocking.</a:t>
             </a:r>
           </a:p>
         </p:txBody>

</xml_diff>

<commit_message>
Demo page: one linear, plain-language story for presenting
The Streamlit page is now one column in five numbered steps for a non-specialist
audience: how good the model is (recall and false-alarm rate at the deployed
threshold, read from reports/tables/threshold.csv), pick an example (caught
malware, safe program, missed malware, false alarm, or upload), the verdict,
the four feature families that pushed it (SHAP sums in plain words), and the
limits. No sidebar or tabs; the raw score and top-10 SHAP table sit in one
"Technical detail" section at the end. Screenshots, report section 7, the
deploy slide, DEMO.md and the page test follow the new layout.

Co-Authored-By: Claude Opus 5.5 <noreply@anthropic.com>
</commit_message>
<xml_diff>
--- a/reports/slides.pptx
+++ b/reports/slides.pptx
@@ -1141,7 +1141,7 @@
           <a:lstStyle/>
           <a:p>
             <a:r>
-              <a:t>Deployment. The tuned LightGBM is served by a FastAPI service and a Streamlit app; you can pick a test_future file or upload a PE file, and the app shows the score, the verdict and the top SHAP reasons. The threshold was chosen on train out-of-fold scores so that a missed malware costs 10 times a false alarm; on test_future that gives 99.5% recall at 7.4% false-positive rate, but at a realistic 1% malware share only about 12% of its alarms would be real malware. So it is a triage aid, not a blocker, and the app says so; the model card lists the limits.</a:t>
+              <a:t>Deployment. The tuned LightGBM is served by a FastAPI service and a one-page Streamlit app; you pick an example file or upload a program, and the page shows the verdict and, in plain words, which parts of the file pushed the decision. The threshold was chosen on train out-of-fold scores so that a missed malware costs 10 times a false alarm; on test_future that gives 99.5% recall at 7.4% false-positive rate, but at a realistic 1% malware share only about 12% of its alarms would be real malware. So it is a triage aid, not a blocker, and the app says so; the model card lists the limits.</a:t>
             </a:r>
           </a:p>
         </p:txBody>
@@ -11049,8 +11049,8 @@
         </p:blipFill>
         <p:spPr>
           <a:xfrm>
-            <a:off x="457200" y="1324555"/>
-            <a:ext cx="6400800" cy="4757530"/>
+            <a:off x="682119" y="1051560"/>
+            <a:ext cx="5950962" cy="5303520"/>
           </a:xfrm>
           <a:prstGeom prst="rect">
             <a:avLst/>
@@ -11125,7 +11125,7 @@
                 </a:solidFill>
                 <a:latin typeface="Calibri"/>
               </a:rPr>
-              <a:t>pick a test_future file or upload a PE; shows P(malicious), verdict and top SHAP reasons.</a:t>
+              <a:t>one page: pick an example or upload a PE; shows the verdict and the top reasons (SHAP) in plain words.</a:t>
             </a:r>
           </a:p>
           <a:p>

</xml_diff>